<commit_message>
modify class/pptx and index.html
</commit_message>
<xml_diff>
--- a/ws01/class/3일차_1.pptx
+++ b/ws01/class/3일차_1.pptx
@@ -16006,54 +16006,87 @@
           <a:bodyPr wrap="square" rtlCol="0" anchor="t"/>
           <a:lstStyle/>
           <a:p>
+            <a:pPr algn="ctr"/>
+            <a:r>
+              <a:rPr lang="en-US" altLang="ko-KR" sz="2100" dirty="0" err="1">
+                <a:solidFill>
+                  <a:srgbClr val="111848"/>
+                </a:solidFill>
+                <a:latin typeface="Calibri" pitchFamily="34" charset="0"/>
+                <a:ea typeface="Calibri" pitchFamily="34" charset="-122"/>
+                <a:cs typeface="Calibri" pitchFamily="34" charset="-120"/>
+              </a:rPr>
+              <a:t>임베딩</a:t>
+            </a:r>
+            <a:r>
+              <a:rPr lang="en-US" altLang="ko-KR" sz="2100" dirty="0">
+                <a:solidFill>
+                  <a:srgbClr val="111848"/>
+                </a:solidFill>
+                <a:latin typeface="Calibri" pitchFamily="34" charset="0"/>
+                <a:ea typeface="Calibri" pitchFamily="34" charset="-122"/>
+                <a:cs typeface="Calibri" pitchFamily="34" charset="-120"/>
+              </a:rPr>
+              <a:t>/</a:t>
+            </a:r>
+            <a:r>
+              <a:rPr lang="en-US" altLang="ko-KR" sz="2100" dirty="0" err="1">
+                <a:solidFill>
+                  <a:srgbClr val="111848"/>
+                </a:solidFill>
+                <a:latin typeface="Calibri" pitchFamily="34" charset="0"/>
+                <a:ea typeface="Calibri" pitchFamily="34" charset="-122"/>
+                <a:cs typeface="Calibri" pitchFamily="34" charset="-120"/>
+              </a:rPr>
+              <a:t>벡터</a:t>
+            </a:r>
+            <a:endParaRPr lang="en-US" altLang="ko-KR" sz="2100" dirty="0"/>
+          </a:p>
+          <a:p>
+            <a:pPr algn="ctr"/>
+            <a:r>
+              <a:rPr lang="en-US" altLang="ko-KR" sz="2100" dirty="0">
+                <a:solidFill>
+                  <a:srgbClr val="111848"/>
+                </a:solidFill>
+                <a:latin typeface="Calibri" pitchFamily="34" charset="0"/>
+                <a:ea typeface="Calibri" pitchFamily="34" charset="-122"/>
+                <a:cs typeface="Calibri" pitchFamily="34" charset="-120"/>
+              </a:rPr>
+              <a:t>DB </a:t>
+            </a:r>
+            <a:r>
+              <a:rPr lang="en-US" altLang="ko-KR" sz="2100" dirty="0" err="1">
+                <a:solidFill>
+                  <a:srgbClr val="111848"/>
+                </a:solidFill>
+                <a:latin typeface="Calibri" pitchFamily="34" charset="0"/>
+                <a:ea typeface="Calibri" pitchFamily="34" charset="-122"/>
+                <a:cs typeface="Calibri" pitchFamily="34" charset="-120"/>
+              </a:rPr>
+              <a:t>취약점</a:t>
+            </a:r>
+            <a:endParaRPr lang="en-US" altLang="ko-KR" sz="2100" dirty="0"/>
+          </a:p>
+          <a:p>
+            <a:pPr algn="ctr"/>
+            <a:r>
+              <a:rPr lang="en-US" altLang="ko-KR" sz="2100" dirty="0" err="1">
+                <a:solidFill>
+                  <a:srgbClr val="111848"/>
+                </a:solidFill>
+                <a:latin typeface="Calibri" pitchFamily="34" charset="0"/>
+                <a:ea typeface="Calibri" pitchFamily="34" charset="-122"/>
+                <a:cs typeface="Calibri" pitchFamily="34" charset="-120"/>
+              </a:rPr>
+              <a:t>실습</a:t>
+            </a:r>
+            <a:endParaRPr lang="en-US" altLang="ko-KR" sz="2100" dirty="0"/>
+          </a:p>
+          <a:p>
             <a:pPr marL="0" indent="0" algn="ctr">
               <a:buNone/>
             </a:pPr>
-            <a:r>
-              <a:rPr lang="en-US" sz="2100" dirty="0">
-                <a:solidFill>
-                  <a:srgbClr val="111848"/>
-                </a:solidFill>
-                <a:latin typeface="Calibri" pitchFamily="34" charset="0"/>
-                <a:ea typeface="Calibri" pitchFamily="34" charset="-122"/>
-                <a:cs typeface="Calibri" pitchFamily="34" charset="-120"/>
-              </a:rPr>
-              <a:t>출력 통제</a:t>
-            </a:r>
-            <a:endParaRPr lang="en-US" sz="2100" dirty="0"/>
-          </a:p>
-          <a:p>
-            <a:pPr marL="0" indent="0" algn="ctr">
-              <a:buNone/>
-            </a:pPr>
-            <a:r>
-              <a:rPr lang="en-US" sz="2100" dirty="0">
-                <a:solidFill>
-                  <a:srgbClr val="111848"/>
-                </a:solidFill>
-                <a:latin typeface="Calibri" pitchFamily="34" charset="0"/>
-                <a:ea typeface="Calibri" pitchFamily="34" charset="-122"/>
-                <a:cs typeface="Calibri" pitchFamily="34" charset="-120"/>
-              </a:rPr>
-              <a:t>데이터 유출</a:t>
-            </a:r>
-            <a:endParaRPr lang="en-US" sz="2100" dirty="0"/>
-          </a:p>
-          <a:p>
-            <a:pPr marL="0" indent="0" algn="ctr">
-              <a:buNone/>
-            </a:pPr>
-            <a:r>
-              <a:rPr lang="en-US" sz="2100" dirty="0">
-                <a:solidFill>
-                  <a:srgbClr val="111848"/>
-                </a:solidFill>
-                <a:latin typeface="Calibri" pitchFamily="34" charset="0"/>
-                <a:ea typeface="Calibri" pitchFamily="34" charset="-122"/>
-                <a:cs typeface="Calibri" pitchFamily="34" charset="-120"/>
-              </a:rPr>
-              <a:t>권한 오남용</a:t>
-            </a:r>
             <a:endParaRPr lang="en-US" sz="2100" dirty="0"/>
           </a:p>
         </p:txBody>
@@ -16291,11 +16324,9 @@
           <a:bodyPr wrap="square" rtlCol="0" anchor="t"/>
           <a:lstStyle/>
           <a:p>
-            <a:pPr marL="0" indent="0" algn="ctr">
-              <a:buNone/>
-            </a:pPr>
-            <a:r>
-              <a:rPr lang="en-US" sz="2100" dirty="0">
+            <a:pPr algn="ctr"/>
+            <a:r>
+              <a:rPr lang="en-US" altLang="ko-KR" sz="2100" dirty="0" err="1">
                 <a:solidFill>
                   <a:srgbClr val="111848"/>
                 </a:solidFill>
@@ -16303,16 +16334,10 @@
                 <a:ea typeface="Calibri" pitchFamily="34" charset="-122"/>
                 <a:cs typeface="Calibri" pitchFamily="34" charset="-120"/>
               </a:rPr>
-              <a:t>임베딩/벡터</a:t>
-            </a:r>
-            <a:endParaRPr lang="en-US" sz="2100" dirty="0"/>
-          </a:p>
-          <a:p>
-            <a:pPr marL="0" indent="0" algn="ctr">
-              <a:buNone/>
-            </a:pPr>
-            <a:r>
-              <a:rPr lang="en-US" sz="2100" dirty="0">
+              <a:t>출력</a:t>
+            </a:r>
+            <a:r>
+              <a:rPr lang="en-US" altLang="ko-KR" sz="2100" dirty="0">
                 <a:solidFill>
                   <a:srgbClr val="111848"/>
                 </a:solidFill>
@@ -16320,16 +16345,10 @@
                 <a:ea typeface="Calibri" pitchFamily="34" charset="-122"/>
                 <a:cs typeface="Calibri" pitchFamily="34" charset="-120"/>
               </a:rPr>
-              <a:t>DB 취약점</a:t>
-            </a:r>
-            <a:endParaRPr lang="en-US" sz="2100" dirty="0"/>
-          </a:p>
-          <a:p>
-            <a:pPr marL="0" indent="0" algn="ctr">
-              <a:buNone/>
-            </a:pPr>
-            <a:r>
-              <a:rPr lang="en-US" sz="2100" dirty="0">
+              <a:t> </a:t>
+            </a:r>
+            <a:r>
+              <a:rPr lang="en-US" altLang="ko-KR" sz="2100" dirty="0" err="1">
                 <a:solidFill>
                   <a:srgbClr val="111848"/>
                 </a:solidFill>
@@ -16337,7 +16356,81 @@
                 <a:ea typeface="Calibri" pitchFamily="34" charset="-122"/>
                 <a:cs typeface="Calibri" pitchFamily="34" charset="-120"/>
               </a:rPr>
-              <a:t>실습</a:t>
+              <a:t>통제</a:t>
+            </a:r>
+            <a:endParaRPr lang="en-US" altLang="ko-KR" sz="2100" dirty="0"/>
+          </a:p>
+          <a:p>
+            <a:pPr algn="ctr"/>
+            <a:r>
+              <a:rPr lang="en-US" altLang="ko-KR" sz="2100" dirty="0" err="1">
+                <a:solidFill>
+                  <a:srgbClr val="111848"/>
+                </a:solidFill>
+                <a:latin typeface="Calibri" pitchFamily="34" charset="0"/>
+                <a:ea typeface="Calibri" pitchFamily="34" charset="-122"/>
+                <a:cs typeface="Calibri" pitchFamily="34" charset="-120"/>
+              </a:rPr>
+              <a:t>데이터</a:t>
+            </a:r>
+            <a:r>
+              <a:rPr lang="en-US" altLang="ko-KR" sz="2100" dirty="0">
+                <a:solidFill>
+                  <a:srgbClr val="111848"/>
+                </a:solidFill>
+                <a:latin typeface="Calibri" pitchFamily="34" charset="0"/>
+                <a:ea typeface="Calibri" pitchFamily="34" charset="-122"/>
+                <a:cs typeface="Calibri" pitchFamily="34" charset="-120"/>
+              </a:rPr>
+              <a:t> </a:t>
+            </a:r>
+            <a:r>
+              <a:rPr lang="en-US" altLang="ko-KR" sz="2100" dirty="0" err="1">
+                <a:solidFill>
+                  <a:srgbClr val="111848"/>
+                </a:solidFill>
+                <a:latin typeface="Calibri" pitchFamily="34" charset="0"/>
+                <a:ea typeface="Calibri" pitchFamily="34" charset="-122"/>
+                <a:cs typeface="Calibri" pitchFamily="34" charset="-120"/>
+              </a:rPr>
+              <a:t>유출</a:t>
+            </a:r>
+            <a:endParaRPr lang="en-US" altLang="ko-KR" sz="2100" dirty="0"/>
+          </a:p>
+          <a:p>
+            <a:pPr algn="ctr"/>
+            <a:r>
+              <a:rPr lang="en-US" altLang="ko-KR" sz="2100" dirty="0" err="1">
+                <a:solidFill>
+                  <a:srgbClr val="111848"/>
+                </a:solidFill>
+                <a:latin typeface="Calibri" pitchFamily="34" charset="0"/>
+                <a:ea typeface="Calibri" pitchFamily="34" charset="-122"/>
+                <a:cs typeface="Calibri" pitchFamily="34" charset="-120"/>
+              </a:rPr>
+              <a:t>권한</a:t>
+            </a:r>
+            <a:r>
+              <a:rPr lang="en-US" altLang="ko-KR" sz="2100" dirty="0">
+                <a:solidFill>
+                  <a:srgbClr val="111848"/>
+                </a:solidFill>
+                <a:latin typeface="Calibri" pitchFamily="34" charset="0"/>
+                <a:ea typeface="Calibri" pitchFamily="34" charset="-122"/>
+                <a:cs typeface="Calibri" pitchFamily="34" charset="-120"/>
+              </a:rPr>
+              <a:t> </a:t>
+            </a:r>
+            <a:r>
+              <a:rPr lang="en-US" altLang="ko-KR" sz="2100" dirty="0" err="1">
+                <a:solidFill>
+                  <a:srgbClr val="111848"/>
+                </a:solidFill>
+                <a:latin typeface="Calibri" pitchFamily="34" charset="0"/>
+                <a:ea typeface="Calibri" pitchFamily="34" charset="-122"/>
+                <a:cs typeface="Calibri" pitchFamily="34" charset="-120"/>
+              </a:rPr>
+              <a:t>오남용</a:t>
             </a:r>
             <a:endParaRPr lang="en-US" sz="2100" dirty="0"/>
           </a:p>
@@ -18972,7 +19065,7 @@
         </p:nvSpPr>
         <p:spPr>
           <a:xfrm>
-            <a:off x="6080760" y="4846320"/>
+            <a:off x="5945850" y="4846320"/>
             <a:ext cx="504395" cy="548640"/>
           </a:xfrm>
           <a:prstGeom prst="rect">
@@ -19011,7 +19104,7 @@
         </p:nvSpPr>
         <p:spPr>
           <a:xfrm>
-            <a:off x="12024360" y="4846320"/>
+            <a:off x="11889450" y="4846320"/>
             <a:ext cx="504395" cy="548640"/>
           </a:xfrm>
           <a:prstGeom prst="rect">
@@ -20530,49 +20623,6 @@
               </a:rPr>
               <a:t>이용자</a:t>
             </a:r>
-            <a:br>
-              <a:rPr lang="en-US" sz="1600" b="1" dirty="0">
-                <a:solidFill>
-                  <a:srgbClr val="FFFFFF"/>
-                </a:solidFill>
-                <a:latin typeface="Calibri" pitchFamily="34" charset="0"/>
-                <a:ea typeface="Calibri" pitchFamily="34" charset="-122"/>
-                <a:cs typeface="Calibri" pitchFamily="34" charset="-120"/>
-              </a:rPr>
-            </a:br>
-            <a:r>
-              <a:rPr lang="en-US" sz="1600" b="1" dirty="0">
-                <a:solidFill>
-                  <a:srgbClr val="FFFFFF"/>
-                </a:solidFill>
-                <a:latin typeface="Calibri" pitchFamily="34" charset="0"/>
-                <a:ea typeface="Calibri" pitchFamily="34" charset="-122"/>
-                <a:cs typeface="Calibri" pitchFamily="34" charset="-120"/>
-              </a:rPr>
-              <a:t>(</a:t>
-            </a:r>
-            <a:r>
-              <a:rPr lang="en-US" sz="1600" b="1" dirty="0" err="1">
-                <a:solidFill>
-                  <a:srgbClr val="FFFFFF"/>
-                </a:solidFill>
-                <a:latin typeface="Calibri" pitchFamily="34" charset="0"/>
-                <a:ea typeface="Calibri" pitchFamily="34" charset="-122"/>
-                <a:cs typeface="Calibri" pitchFamily="34" charset="-120"/>
-              </a:rPr>
-              <a:t>담당자</a:t>
-            </a:r>
-            <a:r>
-              <a:rPr lang="en-US" sz="1600" b="1" dirty="0">
-                <a:solidFill>
-                  <a:srgbClr val="FFFFFF"/>
-                </a:solidFill>
-                <a:latin typeface="Calibri" pitchFamily="34" charset="0"/>
-                <a:ea typeface="Calibri" pitchFamily="34" charset="-122"/>
-                <a:cs typeface="Calibri" pitchFamily="34" charset="-120"/>
-              </a:rPr>
-              <a:t>)</a:t>
-            </a:r>
             <a:endParaRPr lang="en-US" sz="1600" dirty="0"/>
           </a:p>
         </p:txBody>
@@ -21118,7 +21168,7 @@
         </p:nvSpPr>
         <p:spPr>
           <a:xfrm>
-            <a:off x="3255264" y="3757505"/>
+            <a:off x="3255264" y="3712535"/>
             <a:ext cx="164592" cy="457200"/>
           </a:xfrm>
           <a:prstGeom prst="rect">
@@ -21541,7 +21591,7 @@
         </p:nvSpPr>
         <p:spPr>
           <a:xfrm>
-            <a:off x="6199632" y="3757505"/>
+            <a:off x="6199632" y="3712535"/>
             <a:ext cx="164592" cy="457200"/>
           </a:xfrm>
           <a:prstGeom prst="rect">
@@ -21964,7 +22014,7 @@
         </p:nvSpPr>
         <p:spPr>
           <a:xfrm>
-            <a:off x="9144000" y="3757505"/>
+            <a:off x="9144000" y="3712535"/>
             <a:ext cx="164592" cy="457200"/>
           </a:xfrm>
           <a:prstGeom prst="rect">
@@ -22387,7 +22437,7 @@
         </p:nvSpPr>
         <p:spPr>
           <a:xfrm>
-            <a:off x="12088368" y="3757505"/>
+            <a:off x="12088368" y="3712535"/>
             <a:ext cx="164592" cy="457200"/>
           </a:xfrm>
           <a:prstGeom prst="rect">
@@ -22810,7 +22860,7 @@
         </p:nvSpPr>
         <p:spPr>
           <a:xfrm>
-            <a:off x="15032736" y="3757505"/>
+            <a:off x="15032736" y="3712535"/>
             <a:ext cx="164592" cy="457200"/>
           </a:xfrm>
           <a:prstGeom prst="rect">
@@ -31250,9 +31300,86 @@
                 <a:ea typeface="Calibri" pitchFamily="34" charset="-122"/>
                 <a:cs typeface="Calibri" pitchFamily="34" charset="-120"/>
               </a:rPr>
-              <a:t>특수문자 포함 비밀번호, 3개월 주기 변경</a:t>
-            </a:r>
-            <a:endParaRPr lang="en-US" sz="1700" dirty="0"/>
+              <a:t>특수문자 </a:t>
+            </a:r>
+            <a:r>
+              <a:rPr lang="en-US" sz="1700" dirty="0" err="1">
+                <a:solidFill>
+                  <a:srgbClr val="64748B"/>
+                </a:solidFill>
+                <a:latin typeface="Calibri" pitchFamily="34" charset="0"/>
+                <a:ea typeface="Calibri" pitchFamily="34" charset="-122"/>
+                <a:cs typeface="Calibri" pitchFamily="34" charset="-120"/>
+              </a:rPr>
+              <a:t>포함</a:t>
+            </a:r>
+            <a:r>
+              <a:rPr lang="en-US" sz="1700" dirty="0">
+                <a:solidFill>
+                  <a:srgbClr val="64748B"/>
+                </a:solidFill>
+                <a:latin typeface="Calibri" pitchFamily="34" charset="0"/>
+                <a:ea typeface="Calibri" pitchFamily="34" charset="-122"/>
+                <a:cs typeface="Calibri" pitchFamily="34" charset="-120"/>
+              </a:rPr>
+              <a:t> </a:t>
+            </a:r>
+            <a:r>
+              <a:rPr lang="en-US" sz="1700" dirty="0" err="1">
+                <a:solidFill>
+                  <a:srgbClr val="64748B"/>
+                </a:solidFill>
+                <a:latin typeface="Calibri" pitchFamily="34" charset="0"/>
+                <a:ea typeface="Calibri" pitchFamily="34" charset="-122"/>
+                <a:cs typeface="Calibri" pitchFamily="34" charset="-120"/>
+              </a:rPr>
+              <a:t>비밀번호</a:t>
+            </a:r>
+            <a:r>
+              <a:rPr lang="en-US" sz="1700" strike="sngStrike" dirty="0">
+                <a:solidFill>
+                  <a:srgbClr val="64748B"/>
+                </a:solidFill>
+                <a:latin typeface="Calibri" pitchFamily="34" charset="0"/>
+                <a:ea typeface="Calibri" pitchFamily="34" charset="-122"/>
+                <a:cs typeface="Calibri" pitchFamily="34" charset="-120"/>
+              </a:rPr>
+              <a:t>, 3개월 </a:t>
+            </a:r>
+            <a:r>
+              <a:rPr lang="en-US" sz="1700" strike="sngStrike" dirty="0" err="1">
+                <a:solidFill>
+                  <a:srgbClr val="64748B"/>
+                </a:solidFill>
+                <a:latin typeface="Calibri" pitchFamily="34" charset="0"/>
+                <a:ea typeface="Calibri" pitchFamily="34" charset="-122"/>
+                <a:cs typeface="Calibri" pitchFamily="34" charset="-120"/>
+              </a:rPr>
+              <a:t>주기</a:t>
+            </a:r>
+            <a:r>
+              <a:rPr lang="en-US" sz="1700" strike="sngStrike" dirty="0">
+                <a:solidFill>
+                  <a:srgbClr val="64748B"/>
+                </a:solidFill>
+                <a:latin typeface="Calibri" pitchFamily="34" charset="0"/>
+                <a:ea typeface="Calibri" pitchFamily="34" charset="-122"/>
+                <a:cs typeface="Calibri" pitchFamily="34" charset="-120"/>
+              </a:rPr>
+              <a:t> </a:t>
+            </a:r>
+            <a:r>
+              <a:rPr lang="en-US" sz="1700" strike="sngStrike" dirty="0" err="1">
+                <a:solidFill>
+                  <a:srgbClr val="64748B"/>
+                </a:solidFill>
+                <a:latin typeface="Calibri" pitchFamily="34" charset="0"/>
+                <a:ea typeface="Calibri" pitchFamily="34" charset="-122"/>
+                <a:cs typeface="Calibri" pitchFamily="34" charset="-120"/>
+              </a:rPr>
+              <a:t>변경</a:t>
+            </a:r>
+            <a:endParaRPr lang="en-US" sz="1700" strike="sngStrike" dirty="0"/>
           </a:p>
           <a:p>
             <a:pPr marL="0" indent="0">
@@ -37193,7 +37320,7 @@
                 <a:ea typeface="Calibri" pitchFamily="34" charset="-122"/>
                 <a:cs typeface="Calibri" pitchFamily="34" charset="-120"/>
               </a:rPr>
-              <a:t>무엇을 막을지 식별하고, KISA로 </a:t>
+              <a:t>무엇을 막을지 식별하고, </a:t>
             </a:r>
             <a:r>
               <a:rPr lang="en-US" sz="2000" b="1" dirty="0">
@@ -37204,7 +37331,7 @@
                 <a:ea typeface="Calibri" pitchFamily="34" charset="-122"/>
                 <a:cs typeface="Calibri" pitchFamily="34" charset="-120"/>
               </a:rPr>
-              <a:t>누가 언제 </a:t>
+              <a:t>KISA로 누가 언제 </a:t>
             </a:r>
             <a:r>
               <a:rPr lang="en-US" sz="2000" dirty="0">
@@ -38722,7 +38849,7 @@
         </p:nvSpPr>
         <p:spPr>
           <a:xfrm>
-            <a:off x="1828800" y="5394960"/>
+            <a:off x="1828800" y="5208697"/>
             <a:ext cx="6583680" cy="1371600"/>
           </a:xfrm>
           <a:prstGeom prst="rect">
@@ -38782,7 +38909,7 @@
         </p:nvSpPr>
         <p:spPr>
           <a:xfrm>
-            <a:off x="1828800" y="6949440"/>
+            <a:off x="1828800" y="6627713"/>
             <a:ext cx="6583680" cy="1371600"/>
           </a:xfrm>
           <a:prstGeom prst="rect">

</xml_diff>

<commit_message>
add constitution reference files
</commit_message>
<xml_diff>
--- a/ws01/class/3일차_1.pptx
+++ b/ws01/class/3일차_1.pptx
@@ -14321,7 +14321,7 @@
                 <a:ea typeface="Calibri" pitchFamily="34" charset="-122"/>
                 <a:cs typeface="Calibri" pitchFamily="34" charset="-120"/>
               </a:rPr>
-              <a:t>09:00-10:30</a:t>
+              <a:t>09:00-10:10</a:t>
             </a:r>
             <a:endParaRPr lang="en-US" sz="2000" dirty="0"/>
           </a:p>
@@ -14606,7 +14606,7 @@
                 <a:ea typeface="Calibri" pitchFamily="34" charset="-122"/>
                 <a:cs typeface="Calibri" pitchFamily="34" charset="-120"/>
               </a:rPr>
-              <a:t>10:45-12:00</a:t>
+              <a:t>10:20-11:20</a:t>
             </a:r>
             <a:endParaRPr lang="en-US" sz="2000" dirty="0"/>
           </a:p>
@@ -14891,7 +14891,7 @@
                 <a:ea typeface="Calibri" pitchFamily="34" charset="-122"/>
                 <a:cs typeface="Calibri" pitchFamily="34" charset="-120"/>
               </a:rPr>
-              <a:t>13:00-14:30</a:t>
+              <a:t>12:50-14:30</a:t>
             </a:r>
             <a:endParaRPr lang="en-US" sz="2000" dirty="0"/>
           </a:p>
@@ -15725,7 +15725,7 @@
                 <a:ea typeface="Calibri" pitchFamily="34" charset="-122"/>
                 <a:cs typeface="Calibri" pitchFamily="34" charset="-120"/>
               </a:rPr>
-              <a:t>12:00-13:00 점심</a:t>
+              <a:t>11:20-12:50 점심</a:t>
             </a:r>
             <a:endParaRPr lang="en-US" sz="1600" dirty="0"/>
           </a:p>

</xml_diff>